<commit_message>
P2.1 sobre Excel en OneDrive y diapositiva de dos preguntas de repaso en las sesiones 2, 3 y 4
</commit_message>
<xml_diff>
--- a/SESION_2/Sesion_2_Origenes_de_datos_y_logica.pptx
+++ b/SESION_2/Sesion_2_Origenes_de_datos_y_logica.pptx
@@ -8,6 +8,7 @@
     <p:sldId id="256" r:id="rId2"/>
     <p:sldId id="257" r:id="rId3"/>
     <p:sldId id="258" r:id="rId4"/>
+    <p:sldId id="284" r:id="rId35"/>
     <p:sldId id="259" r:id="rId5"/>
     <p:sldId id="260" r:id="rId6"/>
     <p:sldId id="261" r:id="rId7"/>
@@ -2313,6 +2314,94 @@
             <a:fld id="{F7021451-1387-4CA6-816F-3879F97B5CBC}" type="slidenum">
               <a:rPr lang="en-US"/>
               <a:t>28</a:t>
+            </a:fld>
+            <a:endParaRPr lang="en-US"/>
+          </a:p>
+        </p:txBody>
+      </p:sp>
+    </p:spTree>
+    <p:extLst>
+      <p:ext uri="{BB962C8B-B14F-4D97-AF65-F5344CB8AC3E}">
+        <p14:creationId xmlns:p14="http://schemas.microsoft.com/office/powerpoint/2010/main" val="1024086991"/>
+      </p:ext>
+    </p:extLst>
+  </p:cSld>
+  <p:clrMapOvr>
+    <a:masterClrMapping/>
+  </p:clrMapOvr>
+</p:notes>
+</file>
+
+<file path=ppt/notesSlides/notesSlide29.xml><?xml version="1.0" encoding="utf-8"?>
+<p:notes xmlns:a="http://schemas.openxmlformats.org/drawingml/2006/main" xmlns:r="http://schemas.openxmlformats.org/officeDocument/2006/relationships" xmlns:p="http://schemas.openxmlformats.org/presentationml/2006/main">
+  <p:cSld>
+    <p:spTree>
+      <p:nvGrpSpPr>
+        <p:cNvPr id="1" name=""/>
+        <p:cNvGrpSpPr/>
+        <p:nvPr/>
+      </p:nvGrpSpPr>
+      <p:grpSpPr>
+        <a:xfrm>
+          <a:off x="0" y="0"/>
+          <a:ext cx="0" cy="0"/>
+          <a:chOff x="0" y="0"/>
+          <a:chExt cx="0" cy="0"/>
+        </a:xfrm>
+      </p:grpSpPr>
+      <p:sp>
+        <p:nvSpPr>
+          <p:cNvPr id="2" name="Slide Image Placeholder 1"/>
+          <p:cNvSpPr>
+            <a:spLocks noGrp="1" noRot="1" noChangeAspect="1"/>
+          </p:cNvSpPr>
+          <p:nvPr>
+            <p:ph type="sldImg"/>
+          </p:nvPr>
+        </p:nvSpPr>
+        <p:spPr/>
+      </p:sp>
+      <p:sp>
+        <p:nvSpPr>
+          <p:cNvPr id="3" name="Notes Placeholder 2"/>
+          <p:cNvSpPr>
+            <a:spLocks noGrp="1"/>
+          </p:cNvSpPr>
+          <p:nvPr>
+            <p:ph type="body" idx="1"/>
+          </p:nvPr>
+        </p:nvSpPr>
+        <p:spPr/>
+        <p:txBody>
+          <a:bodyPr/>
+          <a:lstStyle/>
+          <a:p>
+            <a:r>
+              <a:rPr lang="en-US" dirty="0"/>
+              <a:t>Respuestas. 1) Guardar crea una versión nueva pero no la reparte: hay que publicar, y los usuarios verán la versión publicada. 2) Back() vuelve a la pantalla anterior e invierte automáticamente la transición con la que llegaste; Navigate exige indicar la pantalla destino. Preguntar a dos alumnos distintos y no alargarlo más de cinco minutos.</a:t>
+            </a:r>
+            <a:endParaRPr lang="en-US" dirty="0"/>
+          </a:p>
+        </p:txBody>
+      </p:sp>
+      <p:sp>
+        <p:nvSpPr>
+          <p:cNvPr id="4" name="Slide Number Placeholder 3"/>
+          <p:cNvSpPr>
+            <a:spLocks noGrp="1"/>
+          </p:cNvSpPr>
+          <p:nvPr>
+            <p:ph type="sldNum" sz="quarter" idx="10"/>
+          </p:nvPr>
+        </p:nvSpPr>
+        <p:spPr/>
+        <p:txBody>
+          <a:bodyPr/>
+          <a:lstStyle/>
+          <a:p>
+            <a:fld id="{F7021451-1387-4CA6-816F-3879F97B5CBC}" type="slidenum">
+              <a:rPr lang="en-US"/>
+              <a:t>1</a:t>
             </a:fld>
             <a:endParaRPr lang="en-US"/>
           </a:p>
@@ -3864,7 +3953,7 @@
                 <a:ea typeface="Calibri" pitchFamily="34" charset="-122"/>
                 <a:cs typeface="Calibri" pitchFamily="34" charset="-120"/>
               </a:rPr>
-              <a:t>10</a:t>
+              <a:t>11</a:t>
             </a:r>
             <a:endParaRPr lang="en-US" sz="900" dirty="0"/>
           </a:p>
@@ -4292,7 +4381,7 @@
                 <a:ea typeface="Calibri" pitchFamily="34" charset="-122"/>
                 <a:cs typeface="Calibri" pitchFamily="34" charset="-120"/>
               </a:rPr>
-              <a:t>11</a:t>
+              <a:t>12</a:t>
             </a:r>
             <a:endParaRPr lang="en-US" sz="900" dirty="0"/>
           </a:p>
@@ -4688,7 +4777,7 @@
                 <a:ea typeface="Calibri" pitchFamily="34" charset="-122"/>
                 <a:cs typeface="Calibri" pitchFamily="34" charset="-120"/>
               </a:rPr>
-              <a:t>12</a:t>
+              <a:t>13</a:t>
             </a:r>
             <a:endParaRPr lang="en-US" sz="900" dirty="0"/>
           </a:p>
@@ -5204,7 +5293,7 @@
                 <a:ea typeface="Calibri" pitchFamily="34" charset="-122"/>
                 <a:cs typeface="Calibri" pitchFamily="34" charset="-120"/>
               </a:rPr>
-              <a:t>13</a:t>
+              <a:t>14</a:t>
             </a:r>
             <a:endParaRPr lang="en-US" sz="900" dirty="0"/>
           </a:p>
@@ -5712,7 +5801,7 @@
                 <a:ea typeface="Calibri" pitchFamily="34" charset="-122"/>
                 <a:cs typeface="Calibri" pitchFamily="34" charset="-120"/>
               </a:rPr>
-              <a:t>14</a:t>
+              <a:t>15</a:t>
             </a:r>
             <a:endParaRPr lang="en-US" sz="900" dirty="0"/>
           </a:p>
@@ -6295,7 +6384,7 @@
                 <a:ea typeface="Calibri" pitchFamily="34" charset="-122"/>
                 <a:cs typeface="Calibri" pitchFamily="34" charset="-120"/>
               </a:rPr>
-              <a:t>15</a:t>
+              <a:t>16</a:t>
             </a:r>
             <a:endParaRPr lang="en-US" sz="900" dirty="0"/>
           </a:p>
@@ -6427,7 +6516,7 @@
                 <a:ea typeface="Cambria" pitchFamily="34" charset="-122"/>
                 <a:cs typeface="Cambria" pitchFamily="34" charset="-120"/>
               </a:rPr>
-              <a:t>App de solicitudes de vacaciones sobre SharePoint</a:t>
+              <a:t>App de solicitudes de vacaciones sobre Excel en OneDrive</a:t>
             </a:r>
             <a:endParaRPr lang="en-US" sz="2800" dirty="0"/>
           </a:p>
@@ -6510,7 +6599,7 @@
                 <a:ea typeface="Calibri" pitchFamily="34" charset="-122"/>
                 <a:cs typeface="Calibri" pitchFamily="34" charset="-120"/>
               </a:rPr>
-              <a:t>Crear la lista con las columnas indicadas</a:t>
+              <a:t>Subir el libro a OneDrive con la tabla Solicitudes</a:t>
             </a:r>
             <a:endParaRPr lang="en-US" sz="1450" dirty="0"/>
           </a:p>
@@ -6532,7 +6621,7 @@
                 <a:ea typeface="Calibri" pitchFamily="34" charset="-122"/>
                 <a:cs typeface="Calibri" pitchFamily="34" charset="-120"/>
               </a:rPr>
-              <a:t>App en blanco conectada a SharePoint</a:t>
+              <a:t>App en blanco conectada a la tabla de Excel</a:t>
             </a:r>
             <a:endParaRPr lang="en-US" sz="1450" dirty="0"/>
           </a:p>
@@ -6576,7 +6665,7 @@
                 <a:ea typeface="Calibri" pitchFamily="34" charset="-122"/>
                 <a:cs typeface="Calibri" pitchFamily="34" charset="-120"/>
               </a:rPr>
-              <a:t>Formulario con días calculados y solicitante automático</a:t>
+              <a:t>Desplegable, selectores de fecha y solicitante automático</a:t>
             </a:r>
             <a:endParaRPr lang="en-US" sz="1450" dirty="0"/>
           </a:p>
@@ -6757,7 +6846,7 @@
                 <a:ea typeface="Calibri" pitchFamily="34" charset="-122"/>
                 <a:cs typeface="Calibri" pitchFamily="34" charset="-120"/>
               </a:rPr>
-              <a:t>Los cambios aparecen en SharePoint</a:t>
+              <a:t>Los cambios aparecen en el Excel de OneDrive</a:t>
             </a:r>
             <a:endParaRPr lang="en-US" sz="1300" dirty="0"/>
           </a:p>
@@ -6877,7 +6966,7 @@
                 <a:ea typeface="Calibri" pitchFamily="34" charset="-122"/>
                 <a:cs typeface="Calibri" pitchFamily="34" charset="-120"/>
               </a:rPr>
-              <a:t>16</a:t>
+              <a:t>17</a:t>
             </a:r>
             <a:endParaRPr lang="en-US" sz="900" dirty="0"/>
           </a:p>
@@ -7065,7 +7154,7 @@
                 <a:ea typeface="Calibri" pitchFamily="34" charset="-122"/>
                 <a:cs typeface="Calibri" pitchFamily="34" charset="-120"/>
               </a:rPr>
-              <a:t>17</a:t>
+              <a:t>18</a:t>
             </a:r>
             <a:endParaRPr lang="en-US" sz="900" dirty="0"/>
           </a:p>
@@ -7405,7 +7494,7 @@
                 <a:ea typeface="Calibri" pitchFamily="34" charset="-122"/>
                 <a:cs typeface="Calibri" pitchFamily="34" charset="-120"/>
               </a:rPr>
-              <a:t>18</a:t>
+              <a:t>19</a:t>
             </a:r>
             <a:endParaRPr lang="en-US" sz="900" dirty="0"/>
           </a:p>
@@ -7886,7 +7975,7 @@
                 <a:ea typeface="Calibri" pitchFamily="34" charset="-122"/>
                 <a:cs typeface="Calibri" pitchFamily="34" charset="-120"/>
               </a:rPr>
-              <a:t>19</a:t>
+              <a:t>20</a:t>
             </a:r>
             <a:endParaRPr lang="en-US" sz="900" dirty="0"/>
           </a:p>
@@ -9760,7 +9849,7 @@
                           <a:ea typeface="Calibri" pitchFamily="34" charset="-122"/>
                           <a:cs typeface="Calibri" pitchFamily="34" charset="-120"/>
                         </a:rPr>
-                        <a:t>P2.1 · App de solicitudes sobre SharePoint</a:t>
+                        <a:t>P2.1 · App de solicitudes sobre Excel en OneDrive</a:t>
                       </a:r>
                       <a:endParaRPr lang="en-US" sz="1250" dirty="0">
                         <a:latin typeface="Calibri" charset="0"/>
@@ -11880,7 +11969,7 @@
                 <a:ea typeface="Calibri" pitchFamily="34" charset="-122"/>
                 <a:cs typeface="Calibri" pitchFamily="34" charset="-120"/>
               </a:rPr>
-              <a:t>20</a:t>
+              <a:t>21</a:t>
             </a:r>
             <a:endParaRPr lang="en-US" sz="900" dirty="0"/>
           </a:p>
@@ -12378,7 +12467,7 @@
                 <a:ea typeface="Calibri" pitchFamily="34" charset="-122"/>
                 <a:cs typeface="Calibri" pitchFamily="34" charset="-120"/>
               </a:rPr>
-              <a:t>21</a:t>
+              <a:t>22</a:t>
             </a:r>
             <a:endParaRPr lang="en-US" sz="900" dirty="0"/>
           </a:p>
@@ -12893,7 +12982,7 @@
                 <a:ea typeface="Calibri" pitchFamily="34" charset="-122"/>
                 <a:cs typeface="Calibri" pitchFamily="34" charset="-120"/>
               </a:rPr>
-              <a:t>22</a:t>
+              <a:t>23</a:t>
             </a:r>
             <a:endParaRPr lang="en-US" sz="900" dirty="0"/>
           </a:p>
@@ -13939,7 +14028,7 @@
                 <a:ea typeface="Calibri" pitchFamily="34" charset="-122"/>
                 <a:cs typeface="Calibri" pitchFamily="34" charset="-120"/>
               </a:rPr>
-              <a:t>23</a:t>
+              <a:t>24</a:t>
             </a:r>
             <a:endParaRPr lang="en-US" sz="900" dirty="0"/>
           </a:p>
@@ -14500,7 +14589,7 @@
                 <a:ea typeface="Calibri" pitchFamily="34" charset="-122"/>
                 <a:cs typeface="Calibri" pitchFamily="34" charset="-120"/>
               </a:rPr>
-              <a:t>24</a:t>
+              <a:t>25</a:t>
             </a:r>
             <a:endParaRPr lang="en-US" sz="900" dirty="0"/>
           </a:p>
@@ -15061,7 +15150,7 @@
                 <a:ea typeface="Calibri" pitchFamily="34" charset="-122"/>
                 <a:cs typeface="Calibri" pitchFamily="34" charset="-120"/>
               </a:rPr>
-              <a:t>25</a:t>
+              <a:t>26</a:t>
             </a:r>
             <a:endParaRPr lang="en-US" sz="900" dirty="0"/>
           </a:p>
@@ -15749,7 +15838,7 @@
                 <a:ea typeface="Calibri" pitchFamily="34" charset="-122"/>
                 <a:cs typeface="Calibri" pitchFamily="34" charset="-120"/>
               </a:rPr>
-              <a:t>26</a:t>
+              <a:t>27</a:t>
             </a:r>
             <a:endParaRPr lang="en-US" sz="900" dirty="0"/>
           </a:p>
@@ -16437,7 +16526,7 @@
                 <a:ea typeface="Calibri" pitchFamily="34" charset="-122"/>
                 <a:cs typeface="Calibri" pitchFamily="34" charset="-120"/>
               </a:rPr>
-              <a:t>27</a:t>
+              <a:t>28</a:t>
             </a:r>
             <a:endParaRPr lang="en-US" sz="900" dirty="0"/>
           </a:p>
@@ -17006,7 +17095,523 @@
                 <a:ea typeface="Calibri" pitchFamily="34" charset="-122"/>
                 <a:cs typeface="Calibri" pitchFamily="34" charset="-120"/>
               </a:rPr>
-              <a:t>28</a:t>
+              <a:t>29</a:t>
+            </a:r>
+            <a:endParaRPr lang="en-US" sz="900" dirty="0"/>
+          </a:p>
+        </p:txBody>
+      </p:sp>
+    </p:spTree>
+  </p:cSld>
+  <p:clrMapOvr>
+    <a:masterClrMapping/>
+  </p:clrMapOvr>
+</p:sld>
+</file>
+
+<file path=ppt/slides/slide29.xml><?xml version="1.0" encoding="utf-8"?>
+<p:sld xmlns:a="http://schemas.openxmlformats.org/drawingml/2006/main" xmlns:r="http://schemas.openxmlformats.org/officeDocument/2006/relationships" xmlns:p="http://schemas.openxmlformats.org/presentationml/2006/main">
+  <p:cSld name="Slide 3">
+    <p:bg>
+      <p:bgPr>
+        <a:solidFill>
+          <a:srgbClr val="FFFFFF"/>
+        </a:solidFill>
+      </p:bgPr>
+    </p:bg>
+    <p:spTree>
+      <p:nvGrpSpPr>
+        <p:cNvPr id="1" name=""/>
+        <p:cNvGrpSpPr/>
+        <p:nvPr/>
+      </p:nvGrpSpPr>
+      <p:grpSpPr>
+        <a:xfrm>
+          <a:off x="0" y="0"/>
+          <a:ext cx="0" cy="0"/>
+          <a:chOff x="0" y="0"/>
+          <a:chExt cx="0" cy="0"/>
+        </a:xfrm>
+      </p:grpSpPr>
+      <p:sp>
+        <p:nvSpPr>
+          <p:cNvPr id="2" name="Text 0"/>
+          <p:cNvSpPr txBox="1"/>
+          <p:nvPr/>
+        </p:nvSpPr>
+        <p:spPr>
+          <a:xfrm>
+            <a:off x="548640" y="347472"/>
+            <a:ext cx="10058400" cy="274320"/>
+          </a:xfrm>
+          <a:prstGeom prst="rect">
+            <a:avLst/>
+          </a:prstGeom>
+          <a:noFill/>
+          <a:ln/>
+        </p:spPr>
+        <p:txBody>
+          <a:bodyPr wrap="square" lIns="0" tIns="0" rIns="0" bIns="0" rtlCol="0" anchor="ctr"/>
+          <a:lstStyle/>
+          <a:p>
+            <a:pPr indent="0" marL="0">
+              <a:buNone/>
+            </a:pPr>
+            <a:r>
+              <a:rPr lang="en-US" sz="1200" b="1" spc="200" kern="0" dirty="0">
+                <a:solidFill>
+                  <a:srgbClr val="742774"/>
+                </a:solidFill>
+                <a:latin typeface="Calibri" pitchFamily="34" charset="0"/>
+                <a:ea typeface="Calibri" pitchFamily="34" charset="-122"/>
+                <a:cs typeface="Calibri" pitchFamily="34" charset="-120"/>
+              </a:rPr>
+              <a:t>DOS PREGUNTAS</a:t>
+            </a:r>
+            <a:endParaRPr lang="en-US" sz="1200" dirty="0"/>
+          </a:p>
+        </p:txBody>
+      </p:sp>
+      <p:sp>
+        <p:nvSpPr>
+          <p:cNvPr id="3" name="Text 1"/>
+          <p:cNvSpPr txBox="1"/>
+          <p:nvPr/>
+        </p:nvSpPr>
+        <p:spPr>
+          <a:xfrm>
+            <a:off x="548640" y="621792"/>
+            <a:ext cx="11064240" cy="685800"/>
+          </a:xfrm>
+          <a:prstGeom prst="rect">
+            <a:avLst/>
+          </a:prstGeom>
+          <a:noFill/>
+          <a:ln/>
+        </p:spPr>
+        <p:txBody>
+          <a:bodyPr wrap="square" lIns="0" tIns="0" rIns="0" bIns="0" rtlCol="0" anchor="t"/>
+          <a:lstStyle/>
+          <a:p>
+            <a:pPr indent="0" marL="0">
+              <a:buNone/>
+            </a:pPr>
+            <a:r>
+              <a:rPr lang="en-US" sz="3000" b="1" dirty="0">
+                <a:solidFill>
+                  <a:srgbClr val="2E1437"/>
+                </a:solidFill>
+                <a:latin typeface="Cambria" pitchFamily="34" charset="0"/>
+                <a:ea typeface="Cambria" pitchFamily="34" charset="-122"/>
+                <a:cs typeface="Cambria" pitchFamily="34" charset="-120"/>
+              </a:rPr>
+              <a:t>Antes de empezar, de la Sesión 1</a:t>
+            </a:r>
+            <a:endParaRPr lang="en-US" sz="3000" dirty="0"/>
+          </a:p>
+        </p:txBody>
+      </p:sp>
+      <p:sp>
+        <p:nvSpPr>
+          <p:cNvPr id="4" name="Shape 2"/>
+          <p:cNvSpPr/>
+          <p:nvPr/>
+        </p:nvSpPr>
+        <p:spPr>
+          <a:xfrm>
+            <a:off x="548640" y="2148840"/>
+            <a:ext cx="5120640" cy="3383280"/>
+          </a:xfrm>
+          <a:prstGeom prst="roundRect">
+            <a:avLst>
+              <a:gd name="adj" fmla="val 4286"/>
+            </a:avLst>
+          </a:prstGeom>
+          <a:solidFill>
+            <a:srgbClr val="F7F3F8"/>
+          </a:solidFill>
+          <a:ln w="9525">
+            <a:solidFill>
+              <a:srgbClr val="E6DDE9"/>
+            </a:solidFill>
+            <a:prstDash val="solid"/>
+          </a:ln>
+        </p:spPr>
+      </p:sp>
+      <p:sp>
+        <p:nvSpPr>
+          <p:cNvPr id="5" name="Shape 3"/>
+          <p:cNvSpPr/>
+          <p:nvPr/>
+        </p:nvSpPr>
+        <p:spPr>
+          <a:xfrm>
+            <a:off x="822960" y="2423160"/>
+            <a:ext cx="566928" cy="566928"/>
+          </a:xfrm>
+          <a:prstGeom prst="ellipse">
+            <a:avLst/>
+          </a:prstGeom>
+          <a:solidFill>
+            <a:srgbClr val="742774"/>
+          </a:solidFill>
+          <a:ln/>
+        </p:spPr>
+      </p:sp>
+      <p:sp>
+        <p:nvSpPr>
+          <p:cNvPr id="6" name="Text 4"/>
+          <p:cNvSpPr txBox="1"/>
+          <p:nvPr/>
+        </p:nvSpPr>
+        <p:spPr>
+          <a:xfrm>
+            <a:off x="822960" y="2423160"/>
+            <a:ext cx="566928" cy="566928"/>
+          </a:xfrm>
+          <a:prstGeom prst="rect">
+            <a:avLst/>
+          </a:prstGeom>
+          <a:noFill/>
+          <a:ln/>
+        </p:spPr>
+        <p:txBody>
+          <a:bodyPr wrap="square" lIns="0" tIns="0" rIns="0" bIns="0" rtlCol="0" anchor="ctr"/>
+          <a:lstStyle/>
+          <a:p>
+            <a:pPr algn="ctr" indent="0" marL="0">
+              <a:buNone/>
+            </a:pPr>
+            <a:r>
+              <a:rPr lang="en-US" sz="1800" b="1" dirty="0">
+                <a:solidFill>
+                  <a:srgbClr val="FFFFFF"/>
+                </a:solidFill>
+                <a:latin typeface="Cambria" pitchFamily="34" charset="0"/>
+                <a:ea typeface="Cambria" pitchFamily="34" charset="-122"/>
+                <a:cs typeface="Cambria" pitchFamily="34" charset="-120"/>
+              </a:rPr>
+              <a:t>1</a:t>
+            </a:r>
+            <a:endParaRPr lang="en-US" sz="1800" dirty="0"/>
+          </a:p>
+        </p:txBody>
+      </p:sp>
+      <p:sp>
+        <p:nvSpPr>
+          <p:cNvPr id="7" name="Text 5"/>
+          <p:cNvSpPr txBox="1"/>
+          <p:nvPr/>
+        </p:nvSpPr>
+        <p:spPr>
+          <a:xfrm>
+            <a:off x="822960" y="3108960"/>
+            <a:ext cx="4572000" cy="640080"/>
+          </a:xfrm>
+          <a:prstGeom prst="rect">
+            <a:avLst/>
+          </a:prstGeom>
+          <a:noFill/>
+          <a:ln/>
+        </p:spPr>
+        <p:txBody>
+          <a:bodyPr wrap="square" lIns="0" tIns="0" rIns="0" bIns="0" rtlCol="0" anchor="t"/>
+          <a:lstStyle/>
+          <a:p>
+            <a:pPr indent="0" marL="0">
+              <a:buNone/>
+            </a:pPr>
+            <a:r>
+              <a:rPr lang="en-US" sz="1800" b="1" dirty="0">
+                <a:solidFill>
+                  <a:srgbClr val="2E1437"/>
+                </a:solidFill>
+                <a:latin typeface="Cambria" pitchFamily="34" charset="0"/>
+                <a:ea typeface="Cambria" pitchFamily="34" charset="-122"/>
+                <a:cs typeface="Cambria" pitchFamily="34" charset="-120"/>
+              </a:rPr>
+              <a:t>¿Guardar o publicar?</a:t>
+            </a:r>
+            <a:endParaRPr lang="en-US" sz="1800" dirty="0"/>
+          </a:p>
+        </p:txBody>
+      </p:sp>
+      <p:sp>
+        <p:nvSpPr>
+          <p:cNvPr id="8" name="Text 6"/>
+          <p:cNvSpPr txBox="1"/>
+          <p:nvPr/>
+        </p:nvSpPr>
+        <p:spPr>
+          <a:xfrm>
+            <a:off x="822960" y="3794760"/>
+            <a:ext cx="4572000" cy="1554480"/>
+          </a:xfrm>
+          <a:prstGeom prst="rect">
+            <a:avLst/>
+          </a:prstGeom>
+          <a:noFill/>
+          <a:ln/>
+        </p:spPr>
+        <p:txBody>
+          <a:bodyPr wrap="square" lIns="0" tIns="0" rIns="0" bIns="0" rtlCol="0" anchor="t"/>
+          <a:lstStyle/>
+          <a:p>
+            <a:pPr indent="0" marL="0">
+              <a:buNone/>
+            </a:pPr>
+            <a:r>
+              <a:rPr lang="en-US" sz="1350" dirty="0">
+                <a:solidFill>
+                  <a:srgbClr val="2B2B33"/>
+                </a:solidFill>
+                <a:latin typeface="Calibri" pitchFamily="34" charset="0"/>
+                <a:ea typeface="Calibri" pitchFamily="34" charset="-122"/>
+                <a:cs typeface="Calibri" pitchFamily="34" charset="-120"/>
+              </a:rPr>
+              <a:t>Una compañera dice que ha guardado la app pero sus usuarios siguen viendo la versión antigua. ¿Qué le falta?</a:t>
+            </a:r>
+            <a:endParaRPr lang="en-US" sz="1350" dirty="0"/>
+          </a:p>
+        </p:txBody>
+      </p:sp>
+      <p:sp>
+        <p:nvSpPr>
+          <p:cNvPr id="9" name="Shape 7"/>
+          <p:cNvSpPr/>
+          <p:nvPr/>
+        </p:nvSpPr>
+        <p:spPr>
+          <a:xfrm>
+            <a:off x="6492240" y="2148840"/>
+            <a:ext cx="5120640" cy="3383280"/>
+          </a:xfrm>
+          <a:prstGeom prst="roundRect">
+            <a:avLst>
+              <a:gd name="adj" fmla="val 4286"/>
+            </a:avLst>
+          </a:prstGeom>
+          <a:solidFill>
+            <a:srgbClr val="F7F3F8"/>
+          </a:solidFill>
+          <a:ln w="9525">
+            <a:solidFill>
+              <a:srgbClr val="E6DDE9"/>
+            </a:solidFill>
+            <a:prstDash val="solid"/>
+          </a:ln>
+        </p:spPr>
+      </p:sp>
+      <p:sp>
+        <p:nvSpPr>
+          <p:cNvPr id="10" name="Shape 8"/>
+          <p:cNvSpPr/>
+          <p:nvPr/>
+        </p:nvSpPr>
+        <p:spPr>
+          <a:xfrm>
+            <a:off x="6766560" y="2423160"/>
+            <a:ext cx="566928" cy="566928"/>
+          </a:xfrm>
+          <a:prstGeom prst="ellipse">
+            <a:avLst/>
+          </a:prstGeom>
+          <a:solidFill>
+            <a:srgbClr val="742774"/>
+          </a:solidFill>
+          <a:ln/>
+        </p:spPr>
+      </p:sp>
+      <p:sp>
+        <p:nvSpPr>
+          <p:cNvPr id="11" name="Text 9"/>
+          <p:cNvSpPr txBox="1"/>
+          <p:nvPr/>
+        </p:nvSpPr>
+        <p:spPr>
+          <a:xfrm>
+            <a:off x="6766560" y="2423160"/>
+            <a:ext cx="566928" cy="566928"/>
+          </a:xfrm>
+          <a:prstGeom prst="rect">
+            <a:avLst/>
+          </a:prstGeom>
+          <a:noFill/>
+          <a:ln/>
+        </p:spPr>
+        <p:txBody>
+          <a:bodyPr wrap="square" lIns="0" tIns="0" rIns="0" bIns="0" rtlCol="0" anchor="ctr"/>
+          <a:lstStyle/>
+          <a:p>
+            <a:pPr algn="ctr" indent="0" marL="0">
+              <a:buNone/>
+            </a:pPr>
+            <a:r>
+              <a:rPr lang="en-US" sz="1800" b="1" dirty="0">
+                <a:solidFill>
+                  <a:srgbClr val="FFFFFF"/>
+                </a:solidFill>
+                <a:latin typeface="Cambria" pitchFamily="34" charset="0"/>
+                <a:ea typeface="Cambria" pitchFamily="34" charset="-122"/>
+                <a:cs typeface="Cambria" pitchFamily="34" charset="-120"/>
+              </a:rPr>
+              <a:t>2</a:t>
+            </a:r>
+            <a:endParaRPr lang="en-US" sz="1800" dirty="0"/>
+          </a:p>
+        </p:txBody>
+      </p:sp>
+      <p:sp>
+        <p:nvSpPr>
+          <p:cNvPr id="12" name="Text 10"/>
+          <p:cNvSpPr txBox="1"/>
+          <p:nvPr/>
+        </p:nvSpPr>
+        <p:spPr>
+          <a:xfrm>
+            <a:off x="6766560" y="3108960"/>
+            <a:ext cx="4572000" cy="640080"/>
+          </a:xfrm>
+          <a:prstGeom prst="rect">
+            <a:avLst/>
+          </a:prstGeom>
+          <a:noFill/>
+          <a:ln/>
+        </p:spPr>
+        <p:txBody>
+          <a:bodyPr wrap="square" lIns="0" tIns="0" rIns="0" bIns="0" rtlCol="0" anchor="t"/>
+          <a:lstStyle/>
+          <a:p>
+            <a:pPr indent="0" marL="0">
+              <a:buNone/>
+            </a:pPr>
+            <a:r>
+              <a:rPr lang="en-US" sz="1800" b="1" dirty="0">
+                <a:solidFill>
+                  <a:srgbClr val="2E1437"/>
+                </a:solidFill>
+                <a:latin typeface="Cambria" pitchFamily="34" charset="0"/>
+                <a:ea typeface="Cambria" pitchFamily="34" charset="-122"/>
+                <a:cs typeface="Cambria" pitchFamily="34" charset="-120"/>
+              </a:rPr>
+              <a:t>¿Navigate o Back?</a:t>
+            </a:r>
+            <a:endParaRPr lang="en-US" sz="1800" dirty="0"/>
+          </a:p>
+        </p:txBody>
+      </p:sp>
+      <p:sp>
+        <p:nvSpPr>
+          <p:cNvPr id="13" name="Text 11"/>
+          <p:cNvSpPr txBox="1"/>
+          <p:nvPr/>
+        </p:nvSpPr>
+        <p:spPr>
+          <a:xfrm>
+            <a:off x="6766560" y="3794760"/>
+            <a:ext cx="4572000" cy="1554480"/>
+          </a:xfrm>
+          <a:prstGeom prst="rect">
+            <a:avLst/>
+          </a:prstGeom>
+          <a:noFill/>
+          <a:ln/>
+        </p:spPr>
+        <p:txBody>
+          <a:bodyPr wrap="square" lIns="0" tIns="0" rIns="0" bIns="0" rtlCol="0" anchor="t"/>
+          <a:lstStyle/>
+          <a:p>
+            <a:pPr indent="0" marL="0">
+              <a:buNone/>
+            </a:pPr>
+            <a:r>
+              <a:rPr lang="en-US" sz="1350" dirty="0">
+                <a:solidFill>
+                  <a:srgbClr val="2B2B33"/>
+                </a:solidFill>
+                <a:latin typeface="Calibri" pitchFamily="34" charset="0"/>
+                <a:ea typeface="Calibri" pitchFamily="34" charset="-122"/>
+                <a:cs typeface="Calibri" pitchFamily="34" charset="-120"/>
+              </a:rPr>
+              <a:t>Quieres volver a la pantalla anterior sin saber cuál era. ¿Qué función usas y qué pasa con la transición?</a:t>
+            </a:r>
+            <a:endParaRPr lang="en-US" sz="1350" dirty="0"/>
+          </a:p>
+        </p:txBody>
+      </p:sp>
+      <p:sp>
+        <p:nvSpPr>
+          <p:cNvPr id="24" name="Text 22"/>
+          <p:cNvSpPr txBox="1"/>
+          <p:nvPr/>
+        </p:nvSpPr>
+        <p:spPr>
+          <a:xfrm>
+            <a:off x="548640" y="6473952"/>
+            <a:ext cx="8229600" cy="228600"/>
+          </a:xfrm>
+          <a:prstGeom prst="rect">
+            <a:avLst/>
+          </a:prstGeom>
+          <a:noFill/>
+          <a:ln/>
+        </p:spPr>
+        <p:txBody>
+          <a:bodyPr wrap="square" lIns="0" tIns="0" rIns="0" bIns="0" rtlCol="0" anchor="ctr"/>
+          <a:lstStyle/>
+          <a:p>
+            <a:pPr indent="0" marL="0">
+              <a:buNone/>
+            </a:pPr>
+            <a:r>
+              <a:rPr lang="en-US" sz="900" dirty="0">
+                <a:solidFill>
+                  <a:srgbClr val="6B6875"/>
+                </a:solidFill>
+                <a:latin typeface="Calibri" pitchFamily="34" charset="0"/>
+                <a:ea typeface="Calibri" pitchFamily="34" charset="-122"/>
+                <a:cs typeface="Calibri" pitchFamily="34" charset="-120"/>
+              </a:rPr>
+              <a:t>Curso Power Apps · Sesión 2 · Orígenes de datos y lógica de aplicaciones</a:t>
+            </a:r>
+            <a:endParaRPr lang="en-US" sz="900" dirty="0"/>
+          </a:p>
+        </p:txBody>
+      </p:sp>
+      <p:sp>
+        <p:nvSpPr>
+          <p:cNvPr id="25" name="Text 23"/>
+          <p:cNvSpPr txBox="1"/>
+          <p:nvPr/>
+        </p:nvSpPr>
+        <p:spPr>
+          <a:xfrm>
+            <a:off x="11185855" y="6473952"/>
+            <a:ext cx="457200" cy="228600"/>
+          </a:xfrm>
+          <a:prstGeom prst="rect">
+            <a:avLst/>
+          </a:prstGeom>
+          <a:noFill/>
+          <a:ln/>
+        </p:spPr>
+        <p:txBody>
+          <a:bodyPr wrap="square" lIns="0" tIns="0" rIns="0" bIns="0" rtlCol="0" anchor="ctr"/>
+          <a:lstStyle/>
+          <a:p>
+            <a:pPr algn="r" indent="0" marL="0">
+              <a:buNone/>
+            </a:pPr>
+            <a:r>
+              <a:rPr lang="en-US" sz="900" dirty="0">
+                <a:solidFill>
+                  <a:srgbClr val="6B6875"/>
+                </a:solidFill>
+                <a:latin typeface="Calibri" pitchFamily="34" charset="0"/>
+                <a:ea typeface="Calibri" pitchFamily="34" charset="-122"/>
+                <a:cs typeface="Calibri" pitchFamily="34" charset="-120"/>
+              </a:rPr>
+              <a:t>4</a:t>
             </a:r>
             <a:endParaRPr lang="en-US" sz="900" dirty="0"/>
           </a:p>
@@ -18169,7 +18774,7 @@
                 <a:ea typeface="Calibri" pitchFamily="34" charset="-122"/>
                 <a:cs typeface="Calibri" pitchFamily="34" charset="-120"/>
               </a:rPr>
-              <a:t>4</a:t>
+              <a:t>5</a:t>
             </a:r>
             <a:endParaRPr lang="en-US" sz="900" dirty="0"/>
           </a:p>
@@ -19759,7 +20364,7 @@
                 <a:ea typeface="Calibri" pitchFamily="34" charset="-122"/>
                 <a:cs typeface="Calibri" pitchFamily="34" charset="-120"/>
               </a:rPr>
-              <a:t>5</a:t>
+              <a:t>6</a:t>
             </a:r>
             <a:endParaRPr lang="en-US" sz="900" dirty="0"/>
           </a:p>
@@ -20155,7 +20760,7 @@
                 <a:ea typeface="Calibri" pitchFamily="34" charset="-122"/>
                 <a:cs typeface="Calibri" pitchFamily="34" charset="-120"/>
               </a:rPr>
-              <a:t>6</a:t>
+              <a:t>7</a:t>
             </a:r>
             <a:endParaRPr lang="en-US" sz="900" dirty="0"/>
           </a:p>
@@ -20540,7 +21145,7 @@
                 <a:ea typeface="Calibri" pitchFamily="34" charset="-122"/>
                 <a:cs typeface="Calibri" pitchFamily="34" charset="-120"/>
               </a:rPr>
-              <a:t>7</a:t>
+              <a:t>8</a:t>
             </a:r>
             <a:endParaRPr lang="en-US" sz="900" dirty="0"/>
           </a:p>
@@ -22201,7 +22806,7 @@
                 <a:ea typeface="Calibri" pitchFamily="34" charset="-122"/>
                 <a:cs typeface="Calibri" pitchFamily="34" charset="-120"/>
               </a:rPr>
-              <a:t>8</a:t>
+              <a:t>9</a:t>
             </a:r>
             <a:endParaRPr lang="en-US" sz="900" dirty="0"/>
           </a:p>
@@ -22640,7 +23245,7 @@
                 <a:ea typeface="Calibri" pitchFamily="34" charset="-122"/>
                 <a:cs typeface="Calibri" pitchFamily="34" charset="-120"/>
               </a:rPr>
-              <a:t>9</a:t>
+              <a:t>10</a:t>
             </a:r>
             <a:endParaRPr lang="en-US" sz="900" dirty="0"/>
           </a:p>

</xml_diff>

<commit_message>
Todo el curso sobre Excel en OneDrive: practicas 3.1, 3.2, 4.1 y 4.2 sin SharePoint, nuevos libros de datos y presentaciones alineadas
</commit_message>
<xml_diff>
--- a/SESION_2/Sesion_2_Origenes_de_datos_y_logica.pptx
+++ b/SESION_2/Sesion_2_Origenes_de_datos_y_logica.pptx
@@ -2114,7 +2114,7 @@
           <a:p>
             <a:r>
               <a:rPr lang="en-US" dirty="0"/>
-              <a:t>Respuesta correcta: B. </a:t>
+              <a:t>Respuesta correcta: A. Guardar la fecha como texto aaaa-mm-dd es lo que permite ordenar con SortByColumns; DateValue sirve para mostrarla, no para ordenar el origen.</a:t>
             </a:r>
             <a:endParaRPr lang="en-US" dirty="0"/>
           </a:p>
@@ -3595,7 +3595,7 @@
                 <a:ea typeface="Calibri" pitchFamily="34" charset="-122"/>
                 <a:cs typeface="Calibri" pitchFamily="34" charset="-120"/>
               </a:rPr>
-              <a:t>SharePoint como repositorio, galerías y formularios para leer y escribir, y Power Fx para dar lógica a la app.</a:t>
+              <a:t>Excel en OneDrive como repositorio, galerías y formularios para leer y escribir, y Power Fx para dar lógica a la app.</a:t>
             </a:r>
             <a:endParaRPr lang="en-US" sz="1600" dirty="0"/>
           </a:p>
@@ -8753,7 +8753,7 @@
                           <a:ea typeface="Calibri" pitchFamily="34" charset="-122"/>
                           <a:cs typeface="Calibri" pitchFamily="34" charset="-120"/>
                         </a:rPr>
-                        <a:t>Bloque A · Orígenes de datos, conectores y SharePoint</a:t>
+                        <a:t>Bloque A · Orígenes de datos, conectores y Excel en OneDrive</a:t>
                       </a:r>
                       <a:endParaRPr lang="en-US" sz="1250" dirty="0">
                         <a:latin typeface="Calibri" charset="0"/>
@@ -9027,7 +9027,7 @@
                           <a:ea typeface="Calibri" pitchFamily="34" charset="-122"/>
                           <a:cs typeface="Calibri" pitchFamily="34" charset="-120"/>
                         </a:rPr>
-                        <a:t>D2.1 · De la lista de SharePoint a la app</a:t>
+                        <a:t>D2.1 · De la tabla de Excel a la app</a:t>
                       </a:r>
                       <a:endParaRPr lang="en-US" sz="1250" dirty="0">
                         <a:latin typeface="Calibri" charset="0"/>
@@ -13348,7 +13348,7 @@
                           <a:ea typeface="Calibri" pitchFamily="34" charset="-122"/>
                           <a:cs typeface="Calibri" pitchFamily="34" charset="-120"/>
                         </a:rPr>
-                        <a:t>El servidor (SharePoint) filtra y devuelve solo lo necesario. Escala a listas grandes.</a:t>
+                        <a:t>El servidor filtra y devuelve solo lo necesario. Escala a orígenes grandes.</a:t>
                       </a:r>
                       <a:endParaRPr lang="en-US" sz="1300" dirty="0">
                         <a:latin typeface="Calibri" charset="0"/>
@@ -13694,7 +13694,7 @@
                           <a:ea typeface="Calibri" pitchFamily="34" charset="-122"/>
                           <a:cs typeface="Calibri" pitchFamily="34" charset="-120"/>
                         </a:rPr>
-                        <a:t>Delegables con SharePoint</a:t>
+                        <a:t>Delegables con SharePoint o Dataverse</a:t>
                       </a:r>
                       <a:endParaRPr lang="en-US" sz="1300" dirty="0">
                         <a:latin typeface="Calibri" charset="0"/>
@@ -13832,7 +13832,7 @@
                           <a:ea typeface="Calibri" pitchFamily="34" charset="-122"/>
                           <a:cs typeface="Calibri" pitchFamily="34" charset="-120"/>
                         </a:rPr>
-                        <a:t>No delegables con SharePoint</a:t>
+                        <a:t>No delegables · con Excel no delega nada</a:t>
                       </a:r>
                       <a:endParaRPr lang="en-US" sz="1300" dirty="0">
                         <a:latin typeface="Calibri" charset="0"/>
@@ -14243,7 +14243,7 @@
                 <a:ea typeface="Calibri" pitchFamily="34" charset="-122"/>
                 <a:cs typeface="Calibri" pitchFamily="34" charset="-120"/>
               </a:rPr>
-              <a:t>Search sobre SharePoint y el aviso de delegación</a:t>
+              <a:t>Search sobre Excel y el aviso de delegación</a:t>
             </a:r>
             <a:endParaRPr lang="en-US" sz="1450" dirty="0"/>
           </a:p>
@@ -15260,7 +15260,7 @@
                 <a:ea typeface="Cambria" pitchFamily="34" charset="-122"/>
                 <a:cs typeface="Cambria" pitchFamily="34" charset="-120"/>
               </a:rPr>
-              <a:t>¿Cómo se muestra el texto de una columna de elección de SharePoint?</a:t>
+              <a:t>¿Cómo se ordena por fecha una columna de texto del Excel?</a:t>
             </a:r>
             <a:endParaRPr lang="en-US" sz="3000" dirty="0"/>
           </a:p>
@@ -15385,7 +15385,7 @@
                 <a:ea typeface="Calibri" pitchFamily="34" charset="-122"/>
                 <a:cs typeface="Calibri" pitchFamily="34" charset="-120"/>
               </a:rPr>
-              <a:t>ThisItem.Estado</a:t>
+              <a:t>Guardando la fecha como aaaa-mm-dd</a:t>
             </a:r>
             <a:endParaRPr lang="en-US" sz="1600" dirty="0"/>
           </a:p>
@@ -15510,7 +15510,7 @@
                 <a:ea typeface="Calibri" pitchFamily="34" charset="-122"/>
                 <a:cs typeface="Calibri" pitchFamily="34" charset="-120"/>
               </a:rPr>
-              <a:t>ThisItem.Estado.Value</a:t>
+              <a:t>Con Sort por el número de serie de Excel</a:t>
             </a:r>
             <a:endParaRPr lang="en-US" sz="1600" dirty="0"/>
           </a:p>
@@ -15635,7 +15635,7 @@
                 <a:ea typeface="Calibri" pitchFamily="34" charset="-122"/>
                 <a:cs typeface="Calibri" pitchFamily="34" charset="-120"/>
               </a:rPr>
-              <a:t>Text(ThisItem.Estado)</a:t>
+              <a:t>No se puede ordenar por fecha</a:t>
             </a:r>
             <a:endParaRPr lang="en-US" sz="1600" dirty="0"/>
           </a:p>
@@ -15760,7 +15760,7 @@
                 <a:ea typeface="Calibri" pitchFamily="34" charset="-122"/>
                 <a:cs typeface="Calibri" pitchFamily="34" charset="-120"/>
               </a:rPr>
-              <a:t>ThisItem.Estado.Text</a:t>
+              <a:t>Convirtiendo cada fila con DateValue en Items</a:t>
             </a:r>
             <a:endParaRPr lang="en-US" sz="1600" dirty="0"/>
           </a:p>
@@ -16448,7 +16448,7 @@
                 <a:ea typeface="Calibri" pitchFamily="34" charset="-122"/>
                 <a:cs typeface="Calibri" pitchFamily="34" charset="-120"/>
               </a:rPr>
-              <a:t>Una columna de SharePoint</a:t>
+              <a:t>Una columna del Excel</a:t>
             </a:r>
             <a:endParaRPr lang="en-US" sz="1600" dirty="0"/>
           </a:p>
@@ -16739,7 +16739,7 @@
                 <a:ea typeface="Calibri" pitchFamily="34" charset="-122"/>
                 <a:cs typeface="Calibri" pitchFamily="34" charset="-120"/>
               </a:rPr>
-              <a:t>SharePoint es un repositorio sólido para apps departamentales; cuida los tipos y nombres de columna.</a:t>
+              <a:t>Excel en OneDrive vale para empezar: cuida los tipos, la delegación y quién tiene el archivo abierto.</a:t>
             </a:r>
             <a:endParaRPr lang="en-US" sz="1700" dirty="0"/>
           </a:p>
@@ -18590,7 +18590,7 @@
                 <a:ea typeface="Cambria" pitchFamily="34" charset="-122"/>
                 <a:cs typeface="Cambria" pitchFamily="34" charset="-120"/>
               </a:rPr>
-              <a:t>Orígenes de datos, conectores y SharePoint</a:t>
+              <a:t>Orígenes de datos, conectores y Excel en OneDrive</a:t>
             </a:r>
             <a:endParaRPr lang="en-US" sz="3600" dirty="0"/>
           </a:p>
@@ -18675,7 +18675,7 @@
                 <a:ea typeface="Calibri" pitchFamily="34" charset="-122"/>
                 <a:cs typeface="Calibri" pitchFamily="34" charset="-120"/>
               </a:rPr>
-              <a:t>SharePoint y sus listas como repositorio de información</a:t>
+              <a:t>Excel en OneDrive y sus tablas como repositorio de información</a:t>
             </a:r>
             <a:endParaRPr lang="en-US" sz="1700" dirty="0"/>
           </a:p>
@@ -22938,7 +22938,7 @@
                 <a:ea typeface="Cambria" pitchFamily="34" charset="-122"/>
                 <a:cs typeface="Cambria" pitchFamily="34" charset="-120"/>
               </a:rPr>
-              <a:t>De la lista de SharePoint a la app en cinco minutos</a:t>
+              <a:t>De la tabla de Excel a la app en cinco minutos</a:t>
             </a:r>
             <a:endParaRPr lang="en-US" sz="2800" dirty="0"/>
           </a:p>
@@ -22977,7 +22977,7 @@
                 <a:ea typeface="Calibri" pitchFamily="34" charset="-122"/>
                 <a:cs typeface="Calibri" pitchFamily="34" charset="-120"/>
               </a:rPr>
-              <a:t>10 minutos · SharePoint y Power Apps Studio</a:t>
+              <a:t>10 minutos · Excel en OneDrive y Power Apps Studio</a:t>
             </a:r>
             <a:endParaRPr lang="en-US" sz="1300" dirty="0"/>
           </a:p>
@@ -23021,7 +23021,7 @@
                 <a:ea typeface="Calibri" pitchFamily="34" charset="-122"/>
                 <a:cs typeface="Calibri" pitchFamily="34" charset="-120"/>
               </a:rPr>
-              <a:t>Crear una lista desde Excel o en blanco</a:t>
+              <a:t>Dar formato de tabla a la hoja y subirla a OneDrive</a:t>
             </a:r>
             <a:endParaRPr lang="en-US" sz="1450" dirty="0"/>
           </a:p>
@@ -23043,7 +23043,7 @@
                 <a:ea typeface="Calibri" pitchFamily="34" charset="-122"/>
                 <a:cs typeface="Calibri" pitchFamily="34" charset="-120"/>
               </a:rPr>
-              <a:t>Integrar &gt; Power Apps &gt; Crear una aplicación</a:t>
+              <a:t>Power Apps &gt; Crear &gt; App desde Excel</a:t>
             </a:r>
             <a:endParaRPr lang="en-US" sz="1450" dirty="0"/>
           </a:p>
@@ -23109,7 +23109,7 @@
                 <a:ea typeface="Calibri" pitchFamily="34" charset="-122"/>
                 <a:cs typeface="Calibri" pitchFamily="34" charset="-120"/>
               </a:rPr>
-              <a:t>Crear un elemento y verlo en la lista</a:t>
+              <a:t>Crear un registro y verlo en el Excel</a:t>
             </a:r>
             <a:endParaRPr lang="en-US" sz="1450" dirty="0"/>
           </a:p>

</xml_diff>